<commit_message>
Replace client placeholders with named anchor clients
Slide 7 of the institutional deck now lists the actual anchor
clients — Rede D'Or São Luiz, Oncoclínicas&Co, Evidia, Topmed
and Leve Saúde — each with segment and short context. Adds a
'+25 unidades / operadoras' scale card highlighting the replication
of the prontuário-com-IA model across credenciada networks.
</commit_message>
<xml_diff>
--- a/doutor_ai_apresentacao_institucional.pptx
+++ b/doutor_ai_apresentacao_institucional.pptx
@@ -15826,7 +15826,7 @@
                 </a:solidFill>
                 <a:latin typeface="JetBrains Mono"/>
               </a:rPr>
-              <a:t>06 · CLIENTES &amp; PERFIS</a:t>
+              <a:t>06 · CLIENTES &amp; PARCEIROS</a:t>
             </a:r>
           </a:p>
         </p:txBody>
@@ -15908,7 +15908,7 @@
                 </a:solidFill>
                 <a:latin typeface="JetBrains Mono"/>
               </a:rPr>
-              <a:t>▸  CLIENTES &amp; PERFIS DE CLIENTE</a:t>
+              <a:t>▸  CLIENTES &amp; PARCEIROS</a:t>
             </a:r>
           </a:p>
         </p:txBody>
@@ -15922,7 +15922,7 @@
         <p:spPr>
           <a:xfrm>
             <a:off x="640080" y="1234440"/>
-            <a:ext cx="10972800" cy="1188720"/>
+            <a:ext cx="11430000" cy="1554480"/>
           </a:xfrm>
           <a:prstGeom prst="rect">
             <a:avLst/>
@@ -15944,22 +15944,38 @@
               </a:lnSpc>
             </a:pPr>
             <a:r>
-              <a:rPr sz="3600" b="1" i="0" spc="-100">
+              <a:rPr sz="3400" b="1" i="0" spc="-100">
                 <a:solidFill>
                   <a:srgbClr val="1A1F2E"/>
                 </a:solidFill>
                 <a:latin typeface="Inter"/>
               </a:rPr>
-              <a:t>Para quem </a:t>
-            </a:r>
-            <a:r>
-              <a:rPr sz="3600" b="1" i="1" spc="-100">
+              <a:t>Construído com </a:t>
+            </a:r>
+            <a:r>
+              <a:rPr sz="3400" b="1" i="1" spc="-100">
                 <a:solidFill>
                   <a:srgbClr val="0071BC"/>
                 </a:solidFill>
                 <a:latin typeface="Inter"/>
               </a:rPr>
-              <a:t>construímos.</a:t>
+              <a:t>instituições</a:t>
+            </a:r>
+          </a:p>
+          <a:p>
+            <a:pPr algn="l">
+              <a:lnSpc>
+                <a:spcPct val="100000"/>
+              </a:lnSpc>
+            </a:pPr>
+            <a:r>
+              <a:rPr sz="3400" b="1" i="1" spc="-100">
+                <a:solidFill>
+                  <a:srgbClr val="0071BC"/>
+                </a:solidFill>
+                <a:latin typeface="Inter"/>
+              </a:rPr>
+              <a:t>de referência.</a:t>
             </a:r>
           </a:p>
         </p:txBody>
@@ -15972,32 +15988,54 @@
         </p:nvSpPr>
         <p:spPr>
           <a:xfrm>
-            <a:off x="640080" y="2606040"/>
-            <a:ext cx="7315200" cy="201168"/>
-          </a:xfrm>
-          <a:prstGeom prst="rect">
-            <a:avLst/>
-          </a:prstGeom>
-          <a:noFill/>
-          <a:ln>
-            <a:noFill/>
-          </a:ln>
-        </p:spPr>
-        <p:txBody>
-          <a:bodyPr wrap="square" lIns="0" tIns="0" rIns="0" bIns="0" anchor="t">
-            <a:spAutoFit/>
-          </a:bodyPr>
-          <a:lstStyle/>
-          <a:p>
-            <a:pPr algn="l"/>
-            <a:r>
-              <a:rPr sz="850" b="1" i="0" spc="160">
-                <a:solidFill>
-                  <a:srgbClr val="0071BC"/>
-                </a:solidFill>
-                <a:latin typeface="JetBrains Mono"/>
-              </a:rPr>
-              <a:t>▸  SEGMENTOS ATENDIDOS</a:t>
+            <a:off x="640080" y="2788920"/>
+            <a:ext cx="10789920" cy="640080"/>
+          </a:xfrm>
+          <a:prstGeom prst="rect">
+            <a:avLst/>
+          </a:prstGeom>
+          <a:noFill/>
+          <a:ln>
+            <a:noFill/>
+          </a:ln>
+        </p:spPr>
+        <p:txBody>
+          <a:bodyPr wrap="square" lIns="0" tIns="0" rIns="0" bIns="0" anchor="t">
+            <a:spAutoFit/>
+          </a:bodyPr>
+          <a:lstStyle/>
+          <a:p>
+            <a:pPr algn="l">
+              <a:lnSpc>
+                <a:spcPct val="145000"/>
+              </a:lnSpc>
+            </a:pPr>
+            <a:r>
+              <a:rPr sz="1250" b="0" i="0">
+                <a:solidFill>
+                  <a:srgbClr val="4B5563"/>
+                </a:solidFill>
+                <a:latin typeface="Inter"/>
+              </a:rPr>
+              <a:t>Aplicações em </a:t>
+            </a:r>
+            <a:r>
+              <a:rPr sz="1250" b="1" i="0">
+                <a:solidFill>
+                  <a:srgbClr val="1A1F2E"/>
+                </a:solidFill>
+                <a:latin typeface="Inter"/>
+              </a:rPr>
+              <a:t>hospitais, redes, operadoras, telemedicina, oncologia e diagnóstico</a:t>
+            </a:r>
+            <a:r>
+              <a:rPr sz="1250" b="0" i="0">
+                <a:solidFill>
+                  <a:srgbClr val="4B5563"/>
+                </a:solidFill>
+                <a:latin typeface="Inter"/>
+              </a:rPr>
+              <a:t> — em fluxos assistenciais e operacionais.</a:t>
             </a:r>
           </a:p>
         </p:txBody>
@@ -16010,718 +16048,8 @@
         </p:nvSpPr>
         <p:spPr>
           <a:xfrm>
-            <a:off x="640080" y="2880360"/>
-            <a:ext cx="2659303" cy="457200"/>
-          </a:xfrm>
-          <a:prstGeom prst="rect">
-            <a:avLst/>
-          </a:prstGeom>
-          <a:solidFill>
-            <a:srgbClr val="FAFAFA"/>
-          </a:solidFill>
-          <a:ln w="6000">
-            <a:solidFill>
-              <a:srgbClr val="D1D5DB"/>
-            </a:solidFill>
-          </a:ln>
-          <a:effectLst/>
-        </p:spPr>
-        <p:style>
-          <a:lnRef idx="1">
-            <a:schemeClr val="accent1"/>
-          </a:lnRef>
-          <a:fillRef idx="3">
-            <a:schemeClr val="accent1"/>
-          </a:fillRef>
-          <a:effectRef idx="2">
-            <a:schemeClr val="accent1"/>
-          </a:effectRef>
-          <a:fontRef idx="minor">
-            <a:schemeClr val="lt1"/>
-          </a:fontRef>
-        </p:style>
-        <p:txBody>
-          <a:bodyPr rtlCol="0" anchor="ctr"/>
-          <a:lstStyle/>
-          <a:p>
-            <a:pPr algn="ctr"/>
-          </a:p>
-        </p:txBody>
-      </p:sp>
-      <p:sp>
-        <p:nvSpPr>
-          <p:cNvPr id="11" name="TextBox 10"/>
-          <p:cNvSpPr txBox="1"/>
-          <p:nvPr/>
-        </p:nvSpPr>
-        <p:spPr>
-          <a:xfrm>
-            <a:off x="804672" y="2880360"/>
-            <a:ext cx="2330119" cy="457200"/>
-          </a:xfrm>
-          <a:prstGeom prst="rect">
-            <a:avLst/>
-          </a:prstGeom>
-          <a:noFill/>
-          <a:ln>
-            <a:noFill/>
-          </a:ln>
-        </p:spPr>
-        <p:txBody>
-          <a:bodyPr wrap="square" lIns="0" tIns="0" rIns="0" bIns="0" anchor="ctr">
-            <a:spAutoFit/>
-          </a:bodyPr>
-          <a:lstStyle/>
-          <a:p>
-            <a:pPr algn="l"/>
-            <a:r>
-              <a:rPr sz="1100" b="1" i="0" spc="-20">
-                <a:solidFill>
-                  <a:srgbClr val="1A1F2E"/>
-                </a:solidFill>
-                <a:latin typeface="Inter"/>
-              </a:rPr>
-              <a:t>Hospitais</a:t>
-            </a:r>
-          </a:p>
-        </p:txBody>
-      </p:sp>
-      <p:sp>
-        <p:nvSpPr>
-          <p:cNvPr id="12" name="Rectangle 11"/>
-          <p:cNvSpPr/>
-          <p:nvPr/>
-        </p:nvSpPr>
-        <p:spPr>
-          <a:xfrm>
-            <a:off x="3390823" y="2880360"/>
-            <a:ext cx="2659303" cy="457200"/>
-          </a:xfrm>
-          <a:prstGeom prst="rect">
-            <a:avLst/>
-          </a:prstGeom>
-          <a:solidFill>
-            <a:srgbClr val="FAFAFA"/>
-          </a:solidFill>
-          <a:ln w="6000">
-            <a:solidFill>
-              <a:srgbClr val="D1D5DB"/>
-            </a:solidFill>
-          </a:ln>
-          <a:effectLst/>
-        </p:spPr>
-        <p:style>
-          <a:lnRef idx="1">
-            <a:schemeClr val="accent1"/>
-          </a:lnRef>
-          <a:fillRef idx="3">
-            <a:schemeClr val="accent1"/>
-          </a:fillRef>
-          <a:effectRef idx="2">
-            <a:schemeClr val="accent1"/>
-          </a:effectRef>
-          <a:fontRef idx="minor">
-            <a:schemeClr val="lt1"/>
-          </a:fontRef>
-        </p:style>
-        <p:txBody>
-          <a:bodyPr rtlCol="0" anchor="ctr"/>
-          <a:lstStyle/>
-          <a:p>
-            <a:pPr algn="ctr"/>
-          </a:p>
-        </p:txBody>
-      </p:sp>
-      <p:sp>
-        <p:nvSpPr>
-          <p:cNvPr id="13" name="TextBox 12"/>
-          <p:cNvSpPr txBox="1"/>
-          <p:nvPr/>
-        </p:nvSpPr>
-        <p:spPr>
-          <a:xfrm>
-            <a:off x="3555415" y="2880360"/>
-            <a:ext cx="2330119" cy="457200"/>
-          </a:xfrm>
-          <a:prstGeom prst="rect">
-            <a:avLst/>
-          </a:prstGeom>
-          <a:noFill/>
-          <a:ln>
-            <a:noFill/>
-          </a:ln>
-        </p:spPr>
-        <p:txBody>
-          <a:bodyPr wrap="square" lIns="0" tIns="0" rIns="0" bIns="0" anchor="ctr">
-            <a:spAutoFit/>
-          </a:bodyPr>
-          <a:lstStyle/>
-          <a:p>
-            <a:pPr algn="l"/>
-            <a:r>
-              <a:rPr sz="1100" b="1" i="0" spc="-20">
-                <a:solidFill>
-                  <a:srgbClr val="1A1F2E"/>
-                </a:solidFill>
-                <a:latin typeface="Inter"/>
-              </a:rPr>
-              <a:t>Redes de saúde</a:t>
-            </a:r>
-          </a:p>
-        </p:txBody>
-      </p:sp>
-      <p:sp>
-        <p:nvSpPr>
-          <p:cNvPr id="14" name="Rectangle 13"/>
-          <p:cNvSpPr/>
-          <p:nvPr/>
-        </p:nvSpPr>
-        <p:spPr>
-          <a:xfrm>
-            <a:off x="6141567" y="2880360"/>
-            <a:ext cx="2659303" cy="457200"/>
-          </a:xfrm>
-          <a:prstGeom prst="rect">
-            <a:avLst/>
-          </a:prstGeom>
-          <a:solidFill>
-            <a:srgbClr val="FAFAFA"/>
-          </a:solidFill>
-          <a:ln w="6000">
-            <a:solidFill>
-              <a:srgbClr val="D1D5DB"/>
-            </a:solidFill>
-          </a:ln>
-          <a:effectLst/>
-        </p:spPr>
-        <p:style>
-          <a:lnRef idx="1">
-            <a:schemeClr val="accent1"/>
-          </a:lnRef>
-          <a:fillRef idx="3">
-            <a:schemeClr val="accent1"/>
-          </a:fillRef>
-          <a:effectRef idx="2">
-            <a:schemeClr val="accent1"/>
-          </a:effectRef>
-          <a:fontRef idx="minor">
-            <a:schemeClr val="lt1"/>
-          </a:fontRef>
-        </p:style>
-        <p:txBody>
-          <a:bodyPr rtlCol="0" anchor="ctr"/>
-          <a:lstStyle/>
-          <a:p>
-            <a:pPr algn="ctr"/>
-          </a:p>
-        </p:txBody>
-      </p:sp>
-      <p:sp>
-        <p:nvSpPr>
-          <p:cNvPr id="15" name="TextBox 14"/>
-          <p:cNvSpPr txBox="1"/>
-          <p:nvPr/>
-        </p:nvSpPr>
-        <p:spPr>
-          <a:xfrm>
-            <a:off x="6306159" y="2880360"/>
-            <a:ext cx="2330119" cy="457200"/>
-          </a:xfrm>
-          <a:prstGeom prst="rect">
-            <a:avLst/>
-          </a:prstGeom>
-          <a:noFill/>
-          <a:ln>
-            <a:noFill/>
-          </a:ln>
-        </p:spPr>
-        <p:txBody>
-          <a:bodyPr wrap="square" lIns="0" tIns="0" rIns="0" bIns="0" anchor="ctr">
-            <a:spAutoFit/>
-          </a:bodyPr>
-          <a:lstStyle/>
-          <a:p>
-            <a:pPr algn="l"/>
-            <a:r>
-              <a:rPr sz="1100" b="1" i="0" spc="-20">
-                <a:solidFill>
-                  <a:srgbClr val="1A1F2E"/>
-                </a:solidFill>
-                <a:latin typeface="Inter"/>
-              </a:rPr>
-              <a:t>Operadoras</a:t>
-            </a:r>
-          </a:p>
-        </p:txBody>
-      </p:sp>
-      <p:sp>
-        <p:nvSpPr>
-          <p:cNvPr id="16" name="Rectangle 15"/>
-          <p:cNvSpPr/>
-          <p:nvPr/>
-        </p:nvSpPr>
-        <p:spPr>
-          <a:xfrm>
-            <a:off x="8892311" y="2880360"/>
-            <a:ext cx="2659303" cy="457200"/>
-          </a:xfrm>
-          <a:prstGeom prst="rect">
-            <a:avLst/>
-          </a:prstGeom>
-          <a:solidFill>
-            <a:srgbClr val="FAFAFA"/>
-          </a:solidFill>
-          <a:ln w="6000">
-            <a:solidFill>
-              <a:srgbClr val="D1D5DB"/>
-            </a:solidFill>
-          </a:ln>
-          <a:effectLst/>
-        </p:spPr>
-        <p:style>
-          <a:lnRef idx="1">
-            <a:schemeClr val="accent1"/>
-          </a:lnRef>
-          <a:fillRef idx="3">
-            <a:schemeClr val="accent1"/>
-          </a:fillRef>
-          <a:effectRef idx="2">
-            <a:schemeClr val="accent1"/>
-          </a:effectRef>
-          <a:fontRef idx="minor">
-            <a:schemeClr val="lt1"/>
-          </a:fontRef>
-        </p:style>
-        <p:txBody>
-          <a:bodyPr rtlCol="0" anchor="ctr"/>
-          <a:lstStyle/>
-          <a:p>
-            <a:pPr algn="ctr"/>
-          </a:p>
-        </p:txBody>
-      </p:sp>
-      <p:sp>
-        <p:nvSpPr>
-          <p:cNvPr id="17" name="TextBox 16"/>
-          <p:cNvSpPr txBox="1"/>
-          <p:nvPr/>
-        </p:nvSpPr>
-        <p:spPr>
-          <a:xfrm>
-            <a:off x="9056903" y="2880360"/>
-            <a:ext cx="2330119" cy="457200"/>
-          </a:xfrm>
-          <a:prstGeom prst="rect">
-            <a:avLst/>
-          </a:prstGeom>
-          <a:noFill/>
-          <a:ln>
-            <a:noFill/>
-          </a:ln>
-        </p:spPr>
-        <p:txBody>
-          <a:bodyPr wrap="square" lIns="0" tIns="0" rIns="0" bIns="0" anchor="ctr">
-            <a:spAutoFit/>
-          </a:bodyPr>
-          <a:lstStyle/>
-          <a:p>
-            <a:pPr algn="l"/>
-            <a:r>
-              <a:rPr sz="1100" b="1" i="0" spc="-20">
-                <a:solidFill>
-                  <a:srgbClr val="1A1F2E"/>
-                </a:solidFill>
-                <a:latin typeface="Inter"/>
-              </a:rPr>
-              <a:t>Clínicas &amp; grupos médicos</a:t>
-            </a:r>
-          </a:p>
-        </p:txBody>
-      </p:sp>
-      <p:sp>
-        <p:nvSpPr>
-          <p:cNvPr id="18" name="Rectangle 17"/>
-          <p:cNvSpPr/>
-          <p:nvPr/>
-        </p:nvSpPr>
-        <p:spPr>
-          <a:xfrm>
-            <a:off x="640080" y="3429000"/>
-            <a:ext cx="2659303" cy="457200"/>
-          </a:xfrm>
-          <a:prstGeom prst="rect">
-            <a:avLst/>
-          </a:prstGeom>
-          <a:solidFill>
-            <a:srgbClr val="FAFAFA"/>
-          </a:solidFill>
-          <a:ln w="6000">
-            <a:solidFill>
-              <a:srgbClr val="D1D5DB"/>
-            </a:solidFill>
-          </a:ln>
-          <a:effectLst/>
-        </p:spPr>
-        <p:style>
-          <a:lnRef idx="1">
-            <a:schemeClr val="accent1"/>
-          </a:lnRef>
-          <a:fillRef idx="3">
-            <a:schemeClr val="accent1"/>
-          </a:fillRef>
-          <a:effectRef idx="2">
-            <a:schemeClr val="accent1"/>
-          </a:effectRef>
-          <a:fontRef idx="minor">
-            <a:schemeClr val="lt1"/>
-          </a:fontRef>
-        </p:style>
-        <p:txBody>
-          <a:bodyPr rtlCol="0" anchor="ctr"/>
-          <a:lstStyle/>
-          <a:p>
-            <a:pPr algn="ctr"/>
-          </a:p>
-        </p:txBody>
-      </p:sp>
-      <p:sp>
-        <p:nvSpPr>
-          <p:cNvPr id="19" name="TextBox 18"/>
-          <p:cNvSpPr txBox="1"/>
-          <p:nvPr/>
-        </p:nvSpPr>
-        <p:spPr>
-          <a:xfrm>
-            <a:off x="804672" y="3429000"/>
-            <a:ext cx="2330119" cy="457200"/>
-          </a:xfrm>
-          <a:prstGeom prst="rect">
-            <a:avLst/>
-          </a:prstGeom>
-          <a:noFill/>
-          <a:ln>
-            <a:noFill/>
-          </a:ln>
-        </p:spPr>
-        <p:txBody>
-          <a:bodyPr wrap="square" lIns="0" tIns="0" rIns="0" bIns="0" anchor="ctr">
-            <a:spAutoFit/>
-          </a:bodyPr>
-          <a:lstStyle/>
-          <a:p>
-            <a:pPr algn="l"/>
-            <a:r>
-              <a:rPr sz="1100" b="1" i="0" spc="-20">
-                <a:solidFill>
-                  <a:srgbClr val="1A1F2E"/>
-                </a:solidFill>
-                <a:latin typeface="Inter"/>
-              </a:rPr>
-              <a:t>Plataformas de telemedicina</a:t>
-            </a:r>
-          </a:p>
-        </p:txBody>
-      </p:sp>
-      <p:sp>
-        <p:nvSpPr>
-          <p:cNvPr id="20" name="Rectangle 19"/>
-          <p:cNvSpPr/>
-          <p:nvPr/>
-        </p:nvSpPr>
-        <p:spPr>
-          <a:xfrm>
-            <a:off x="3390823" y="3429000"/>
-            <a:ext cx="2659303" cy="457200"/>
-          </a:xfrm>
-          <a:prstGeom prst="rect">
-            <a:avLst/>
-          </a:prstGeom>
-          <a:solidFill>
-            <a:srgbClr val="FAFAFA"/>
-          </a:solidFill>
-          <a:ln w="6000">
-            <a:solidFill>
-              <a:srgbClr val="D1D5DB"/>
-            </a:solidFill>
-          </a:ln>
-          <a:effectLst/>
-        </p:spPr>
-        <p:style>
-          <a:lnRef idx="1">
-            <a:schemeClr val="accent1"/>
-          </a:lnRef>
-          <a:fillRef idx="3">
-            <a:schemeClr val="accent1"/>
-          </a:fillRef>
-          <a:effectRef idx="2">
-            <a:schemeClr val="accent1"/>
-          </a:effectRef>
-          <a:fontRef idx="minor">
-            <a:schemeClr val="lt1"/>
-          </a:fontRef>
-        </p:style>
-        <p:txBody>
-          <a:bodyPr rtlCol="0" anchor="ctr"/>
-          <a:lstStyle/>
-          <a:p>
-            <a:pPr algn="ctr"/>
-          </a:p>
-        </p:txBody>
-      </p:sp>
-      <p:sp>
-        <p:nvSpPr>
-          <p:cNvPr id="21" name="TextBox 20"/>
-          <p:cNvSpPr txBox="1"/>
-          <p:nvPr/>
-        </p:nvSpPr>
-        <p:spPr>
-          <a:xfrm>
-            <a:off x="3555415" y="3429000"/>
-            <a:ext cx="2330119" cy="457200"/>
-          </a:xfrm>
-          <a:prstGeom prst="rect">
-            <a:avLst/>
-          </a:prstGeom>
-          <a:noFill/>
-          <a:ln>
-            <a:noFill/>
-          </a:ln>
-        </p:spPr>
-        <p:txBody>
-          <a:bodyPr wrap="square" lIns="0" tIns="0" rIns="0" bIns="0" anchor="ctr">
-            <a:spAutoFit/>
-          </a:bodyPr>
-          <a:lstStyle/>
-          <a:p>
-            <a:pPr algn="l"/>
-            <a:r>
-              <a:rPr sz="1100" b="1" i="0" spc="-20">
-                <a:solidFill>
-                  <a:srgbClr val="1A1F2E"/>
-                </a:solidFill>
-                <a:latin typeface="Inter"/>
-              </a:rPr>
-              <a:t>Empresas de gestão assistencial</a:t>
-            </a:r>
-          </a:p>
-        </p:txBody>
-      </p:sp>
-      <p:sp>
-        <p:nvSpPr>
-          <p:cNvPr id="22" name="Rectangle 21"/>
-          <p:cNvSpPr/>
-          <p:nvPr/>
-        </p:nvSpPr>
-        <p:spPr>
-          <a:xfrm>
-            <a:off x="6141567" y="3429000"/>
-            <a:ext cx="2659303" cy="457200"/>
-          </a:xfrm>
-          <a:prstGeom prst="rect">
-            <a:avLst/>
-          </a:prstGeom>
-          <a:solidFill>
-            <a:srgbClr val="FAFAFA"/>
-          </a:solidFill>
-          <a:ln w="6000">
-            <a:solidFill>
-              <a:srgbClr val="D1D5DB"/>
-            </a:solidFill>
-          </a:ln>
-          <a:effectLst/>
-        </p:spPr>
-        <p:style>
-          <a:lnRef idx="1">
-            <a:schemeClr val="accent1"/>
-          </a:lnRef>
-          <a:fillRef idx="3">
-            <a:schemeClr val="accent1"/>
-          </a:fillRef>
-          <a:effectRef idx="2">
-            <a:schemeClr val="accent1"/>
-          </a:effectRef>
-          <a:fontRef idx="minor">
-            <a:schemeClr val="lt1"/>
-          </a:fontRef>
-        </p:style>
-        <p:txBody>
-          <a:bodyPr rtlCol="0" anchor="ctr"/>
-          <a:lstStyle/>
-          <a:p>
-            <a:pPr algn="ctr"/>
-          </a:p>
-        </p:txBody>
-      </p:sp>
-      <p:sp>
-        <p:nvSpPr>
-          <p:cNvPr id="23" name="TextBox 22"/>
-          <p:cNvSpPr txBox="1"/>
-          <p:nvPr/>
-        </p:nvSpPr>
-        <p:spPr>
-          <a:xfrm>
-            <a:off x="6306159" y="3429000"/>
-            <a:ext cx="2330119" cy="457200"/>
-          </a:xfrm>
-          <a:prstGeom prst="rect">
-            <a:avLst/>
-          </a:prstGeom>
-          <a:noFill/>
-          <a:ln>
-            <a:noFill/>
-          </a:ln>
-        </p:spPr>
-        <p:txBody>
-          <a:bodyPr wrap="square" lIns="0" tIns="0" rIns="0" bIns="0" anchor="ctr">
-            <a:spAutoFit/>
-          </a:bodyPr>
-          <a:lstStyle/>
-          <a:p>
-            <a:pPr algn="l"/>
-            <a:r>
-              <a:rPr sz="1100" b="1" i="0" spc="-20">
-                <a:solidFill>
-                  <a:srgbClr val="1A1F2E"/>
-                </a:solidFill>
-                <a:latin typeface="Inter"/>
-              </a:rPr>
-              <a:t>Parceiros estratégicos</a:t>
-            </a:r>
-          </a:p>
-        </p:txBody>
-      </p:sp>
-      <p:sp>
-        <p:nvSpPr>
-          <p:cNvPr id="24" name="Rectangle 23"/>
-          <p:cNvSpPr/>
-          <p:nvPr/>
-        </p:nvSpPr>
-        <p:spPr>
-          <a:xfrm>
-            <a:off x="8892311" y="3429000"/>
-            <a:ext cx="2659303" cy="457200"/>
-          </a:xfrm>
-          <a:prstGeom prst="rect">
-            <a:avLst/>
-          </a:prstGeom>
-          <a:solidFill>
-            <a:srgbClr val="FAFAFA"/>
-          </a:solidFill>
-          <a:ln w="6000">
-            <a:solidFill>
-              <a:srgbClr val="D1D5DB"/>
-            </a:solidFill>
-          </a:ln>
-          <a:effectLst/>
-        </p:spPr>
-        <p:style>
-          <a:lnRef idx="1">
-            <a:schemeClr val="accent1"/>
-          </a:lnRef>
-          <a:fillRef idx="3">
-            <a:schemeClr val="accent1"/>
-          </a:fillRef>
-          <a:effectRef idx="2">
-            <a:schemeClr val="accent1"/>
-          </a:effectRef>
-          <a:fontRef idx="minor">
-            <a:schemeClr val="lt1"/>
-          </a:fontRef>
-        </p:style>
-        <p:txBody>
-          <a:bodyPr rtlCol="0" anchor="ctr"/>
-          <a:lstStyle/>
-          <a:p>
-            <a:pPr algn="ctr"/>
-          </a:p>
-        </p:txBody>
-      </p:sp>
-      <p:sp>
-        <p:nvSpPr>
-          <p:cNvPr id="25" name="TextBox 24"/>
-          <p:cNvSpPr txBox="1"/>
-          <p:nvPr/>
-        </p:nvSpPr>
-        <p:spPr>
-          <a:xfrm>
-            <a:off x="9056903" y="3429000"/>
-            <a:ext cx="2330119" cy="457200"/>
-          </a:xfrm>
-          <a:prstGeom prst="rect">
-            <a:avLst/>
-          </a:prstGeom>
-          <a:noFill/>
-          <a:ln>
-            <a:noFill/>
-          </a:ln>
-        </p:spPr>
-        <p:txBody>
-          <a:bodyPr wrap="square" lIns="0" tIns="0" rIns="0" bIns="0" anchor="ctr">
-            <a:spAutoFit/>
-          </a:bodyPr>
-          <a:lstStyle/>
-          <a:p>
-            <a:pPr algn="l"/>
-            <a:r>
-              <a:rPr sz="1100" b="1" i="0" spc="-20">
-                <a:solidFill>
-                  <a:srgbClr val="1A1F2E"/>
-                </a:solidFill>
-                <a:latin typeface="Inter"/>
-              </a:rPr>
-              <a:t>Healthtechs &amp; integradores</a:t>
-            </a:r>
-          </a:p>
-        </p:txBody>
-      </p:sp>
-      <p:sp>
-        <p:nvSpPr>
-          <p:cNvPr id="26" name="TextBox 25"/>
-          <p:cNvSpPr txBox="1"/>
-          <p:nvPr/>
-        </p:nvSpPr>
-        <p:spPr>
-          <a:xfrm>
-            <a:off x="640080" y="4160520"/>
-            <a:ext cx="10058400" cy="201168"/>
-          </a:xfrm>
-          <a:prstGeom prst="rect">
-            <a:avLst/>
-          </a:prstGeom>
-          <a:noFill/>
-          <a:ln>
-            <a:noFill/>
-          </a:ln>
-        </p:spPr>
-        <p:txBody>
-          <a:bodyPr wrap="square" lIns="0" tIns="0" rIns="0" bIns="0" anchor="t">
-            <a:spAutoFit/>
-          </a:bodyPr>
-          <a:lstStyle/>
-          <a:p>
-            <a:pPr algn="l"/>
-            <a:r>
-              <a:rPr sz="850" b="1" i="0" spc="160">
-                <a:solidFill>
-                  <a:srgbClr val="0071BC"/>
-                </a:solidFill>
-                <a:latin typeface="JetBrains Mono"/>
-              </a:rPr>
-              <a:t>▸  REFERÊNCIAS E CONVERSAS COMERCIAIS A VALIDAR</a:t>
-            </a:r>
-          </a:p>
-        </p:txBody>
-      </p:sp>
-      <p:sp>
-        <p:nvSpPr>
-          <p:cNvPr id="27" name="Rectangle 26"/>
-          <p:cNvSpPr/>
-          <p:nvPr/>
-        </p:nvSpPr>
-        <p:spPr>
-          <a:xfrm>
-            <a:off x="640080" y="4434840"/>
-            <a:ext cx="2659303" cy="640080"/>
+            <a:off x="640080" y="3611880"/>
+            <a:ext cx="2109155" cy="1691640"/>
           </a:xfrm>
           <a:prstGeom prst="rect">
             <a:avLst/>
@@ -16733,7 +16061,6 @@
             <a:solidFill>
               <a:srgbClr val="D1D5DB"/>
             </a:solidFill>
-            <a:prstDash val="dash"/>
           </a:ln>
           <a:effectLst/>
         </p:spPr>
@@ -16761,52 +16088,136 @@
       </p:sp>
       <p:sp>
         <p:nvSpPr>
-          <p:cNvPr id="28" name="TextBox 27"/>
-          <p:cNvSpPr txBox="1"/>
-          <p:nvPr/>
-        </p:nvSpPr>
-        <p:spPr>
-          <a:xfrm>
-            <a:off x="640080" y="4434840"/>
-            <a:ext cx="2659303" cy="640080"/>
-          </a:xfrm>
-          <a:prstGeom prst="rect">
-            <a:avLst/>
-          </a:prstGeom>
-          <a:noFill/>
-          <a:ln>
-            <a:noFill/>
-          </a:ln>
-        </p:spPr>
-        <p:txBody>
-          <a:bodyPr wrap="square" lIns="0" tIns="0" rIns="0" bIns="0" anchor="ctr">
-            <a:spAutoFit/>
-          </a:bodyPr>
-          <a:lstStyle/>
-          <a:p>
-            <a:pPr algn="ctr"/>
-            <a:r>
-              <a:rPr sz="1050" b="0" i="0">
-                <a:solidFill>
-                  <a:srgbClr val="9CA3AF"/>
-                </a:solidFill>
-                <a:latin typeface="Inter"/>
-              </a:rPr>
-              <a:t>[ Referência a validar ]</a:t>
-            </a:r>
-          </a:p>
-        </p:txBody>
-      </p:sp>
-      <p:sp>
-        <p:nvSpPr>
-          <p:cNvPr id="29" name="Rectangle 28"/>
+          <p:cNvPr id="11" name="TextBox 10"/>
+          <p:cNvSpPr txBox="1"/>
+          <p:nvPr/>
+        </p:nvSpPr>
+        <p:spPr>
+          <a:xfrm>
+            <a:off x="804672" y="3776472"/>
+            <a:ext cx="1779971" cy="219456"/>
+          </a:xfrm>
+          <a:prstGeom prst="rect">
+            <a:avLst/>
+          </a:prstGeom>
+          <a:noFill/>
+          <a:ln>
+            <a:noFill/>
+          </a:ln>
+        </p:spPr>
+        <p:txBody>
+          <a:bodyPr wrap="square" lIns="0" tIns="0" rIns="0" bIns="0" anchor="t">
+            <a:spAutoFit/>
+          </a:bodyPr>
+          <a:lstStyle/>
+          <a:p>
+            <a:pPr algn="l"/>
+            <a:r>
+              <a:rPr sz="800" b="1" i="0" spc="170">
+                <a:solidFill>
+                  <a:srgbClr val="0071BC"/>
+                </a:solidFill>
+                <a:latin typeface="JetBrains Mono"/>
+              </a:rPr>
+              <a:t>REDE HOSPITALAR</a:t>
+            </a:r>
+          </a:p>
+        </p:txBody>
+      </p:sp>
+      <p:sp>
+        <p:nvSpPr>
+          <p:cNvPr id="12" name="TextBox 11"/>
+          <p:cNvSpPr txBox="1"/>
+          <p:nvPr/>
+        </p:nvSpPr>
+        <p:spPr>
+          <a:xfrm>
+            <a:off x="804672" y="4050792"/>
+            <a:ext cx="1779971" cy="548640"/>
+          </a:xfrm>
+          <a:prstGeom prst="rect">
+            <a:avLst/>
+          </a:prstGeom>
+          <a:noFill/>
+          <a:ln>
+            <a:noFill/>
+          </a:ln>
+        </p:spPr>
+        <p:txBody>
+          <a:bodyPr wrap="square" lIns="0" tIns="0" rIns="0" bIns="0" anchor="t">
+            <a:spAutoFit/>
+          </a:bodyPr>
+          <a:lstStyle/>
+          <a:p>
+            <a:pPr algn="l">
+              <a:lnSpc>
+                <a:spcPct val="110000"/>
+              </a:lnSpc>
+            </a:pPr>
+            <a:r>
+              <a:rPr sz="1400" b="1" i="0" spc="-50">
+                <a:solidFill>
+                  <a:srgbClr val="1A1F2E"/>
+                </a:solidFill>
+                <a:latin typeface="Inter"/>
+              </a:rPr>
+              <a:t>Rede D'Or São Luiz</a:t>
+            </a:r>
+          </a:p>
+        </p:txBody>
+      </p:sp>
+      <p:sp>
+        <p:nvSpPr>
+          <p:cNvPr id="13" name="TextBox 12"/>
+          <p:cNvSpPr txBox="1"/>
+          <p:nvPr/>
+        </p:nvSpPr>
+        <p:spPr>
+          <a:xfrm>
+            <a:off x="804672" y="4645152"/>
+            <a:ext cx="1779971" cy="640080"/>
+          </a:xfrm>
+          <a:prstGeom prst="rect">
+            <a:avLst/>
+          </a:prstGeom>
+          <a:noFill/>
+          <a:ln>
+            <a:noFill/>
+          </a:ln>
+        </p:spPr>
+        <p:txBody>
+          <a:bodyPr wrap="square" lIns="0" tIns="0" rIns="0" bIns="0" anchor="t">
+            <a:spAutoFit/>
+          </a:bodyPr>
+          <a:lstStyle/>
+          <a:p>
+            <a:pPr algn="l">
+              <a:lnSpc>
+                <a:spcPct val="140000"/>
+              </a:lnSpc>
+            </a:pPr>
+            <a:r>
+              <a:rPr sz="900" b="0" i="0">
+                <a:solidFill>
+                  <a:srgbClr val="4B5563"/>
+                </a:solidFill>
+                <a:latin typeface="Inter"/>
+              </a:rPr>
+              <a:t>Jornadas assistenciais e operacionais em ambiente hospitalar.</a:t>
+            </a:r>
+          </a:p>
+        </p:txBody>
+      </p:sp>
+      <p:sp>
+        <p:nvSpPr>
+          <p:cNvPr id="14" name="Rectangle 13"/>
           <p:cNvSpPr/>
           <p:nvPr/>
         </p:nvSpPr>
         <p:spPr>
           <a:xfrm>
-            <a:off x="3390823" y="4434840"/>
-            <a:ext cx="2659303" cy="640080"/>
+            <a:off x="2840675" y="3611880"/>
+            <a:ext cx="2109155" cy="1691640"/>
           </a:xfrm>
           <a:prstGeom prst="rect">
             <a:avLst/>
@@ -16818,7 +16229,6 @@
             <a:solidFill>
               <a:srgbClr val="D1D5DB"/>
             </a:solidFill>
-            <a:prstDash val="dash"/>
           </a:ln>
           <a:effectLst/>
         </p:spPr>
@@ -16846,52 +16256,136 @@
       </p:sp>
       <p:sp>
         <p:nvSpPr>
-          <p:cNvPr id="30" name="TextBox 29"/>
-          <p:cNvSpPr txBox="1"/>
-          <p:nvPr/>
-        </p:nvSpPr>
-        <p:spPr>
-          <a:xfrm>
-            <a:off x="3390823" y="4434840"/>
-            <a:ext cx="2659303" cy="640080"/>
-          </a:xfrm>
-          <a:prstGeom prst="rect">
-            <a:avLst/>
-          </a:prstGeom>
-          <a:noFill/>
-          <a:ln>
-            <a:noFill/>
-          </a:ln>
-        </p:spPr>
-        <p:txBody>
-          <a:bodyPr wrap="square" lIns="0" tIns="0" rIns="0" bIns="0" anchor="ctr">
-            <a:spAutoFit/>
-          </a:bodyPr>
-          <a:lstStyle/>
-          <a:p>
-            <a:pPr algn="ctr"/>
-            <a:r>
-              <a:rPr sz="1050" b="0" i="0">
-                <a:solidFill>
-                  <a:srgbClr val="9CA3AF"/>
-                </a:solidFill>
-                <a:latin typeface="Inter"/>
-              </a:rPr>
-              <a:t>[ Referência a validar ]</a:t>
-            </a:r>
-          </a:p>
-        </p:txBody>
-      </p:sp>
-      <p:sp>
-        <p:nvSpPr>
-          <p:cNvPr id="31" name="Rectangle 30"/>
+          <p:cNvPr id="15" name="TextBox 14"/>
+          <p:cNvSpPr txBox="1"/>
+          <p:nvPr/>
+        </p:nvSpPr>
+        <p:spPr>
+          <a:xfrm>
+            <a:off x="3005267" y="3776472"/>
+            <a:ext cx="1779971" cy="219456"/>
+          </a:xfrm>
+          <a:prstGeom prst="rect">
+            <a:avLst/>
+          </a:prstGeom>
+          <a:noFill/>
+          <a:ln>
+            <a:noFill/>
+          </a:ln>
+        </p:spPr>
+        <p:txBody>
+          <a:bodyPr wrap="square" lIns="0" tIns="0" rIns="0" bIns="0" anchor="t">
+            <a:spAutoFit/>
+          </a:bodyPr>
+          <a:lstStyle/>
+          <a:p>
+            <a:pPr algn="l"/>
+            <a:r>
+              <a:rPr sz="800" b="1" i="0" spc="170">
+                <a:solidFill>
+                  <a:srgbClr val="0071BC"/>
+                </a:solidFill>
+                <a:latin typeface="JetBrains Mono"/>
+              </a:rPr>
+              <a:t>ONCOLOGIA</a:t>
+            </a:r>
+          </a:p>
+        </p:txBody>
+      </p:sp>
+      <p:sp>
+        <p:nvSpPr>
+          <p:cNvPr id="16" name="TextBox 15"/>
+          <p:cNvSpPr txBox="1"/>
+          <p:nvPr/>
+        </p:nvSpPr>
+        <p:spPr>
+          <a:xfrm>
+            <a:off x="3005267" y="4050792"/>
+            <a:ext cx="1779971" cy="548640"/>
+          </a:xfrm>
+          <a:prstGeom prst="rect">
+            <a:avLst/>
+          </a:prstGeom>
+          <a:noFill/>
+          <a:ln>
+            <a:noFill/>
+          </a:ln>
+        </p:spPr>
+        <p:txBody>
+          <a:bodyPr wrap="square" lIns="0" tIns="0" rIns="0" bIns="0" anchor="t">
+            <a:spAutoFit/>
+          </a:bodyPr>
+          <a:lstStyle/>
+          <a:p>
+            <a:pPr algn="l">
+              <a:lnSpc>
+                <a:spcPct val="110000"/>
+              </a:lnSpc>
+            </a:pPr>
+            <a:r>
+              <a:rPr sz="1400" b="1" i="0" spc="-50">
+                <a:solidFill>
+                  <a:srgbClr val="1A1F2E"/>
+                </a:solidFill>
+                <a:latin typeface="Inter"/>
+              </a:rPr>
+              <a:t>Oncoclínicas&amp;Co</a:t>
+            </a:r>
+          </a:p>
+        </p:txBody>
+      </p:sp>
+      <p:sp>
+        <p:nvSpPr>
+          <p:cNvPr id="17" name="TextBox 16"/>
+          <p:cNvSpPr txBox="1"/>
+          <p:nvPr/>
+        </p:nvSpPr>
+        <p:spPr>
+          <a:xfrm>
+            <a:off x="3005267" y="4645152"/>
+            <a:ext cx="1779971" cy="640080"/>
+          </a:xfrm>
+          <a:prstGeom prst="rect">
+            <a:avLst/>
+          </a:prstGeom>
+          <a:noFill/>
+          <a:ln>
+            <a:noFill/>
+          </a:ln>
+        </p:spPr>
+        <p:txBody>
+          <a:bodyPr wrap="square" lIns="0" tIns="0" rIns="0" bIns="0" anchor="t">
+            <a:spAutoFit/>
+          </a:bodyPr>
+          <a:lstStyle/>
+          <a:p>
+            <a:pPr algn="l">
+              <a:lnSpc>
+                <a:spcPct val="140000"/>
+              </a:lnSpc>
+            </a:pPr>
+            <a:r>
+              <a:rPr sz="900" b="0" i="0">
+                <a:solidFill>
+                  <a:srgbClr val="4B5563"/>
+                </a:solidFill>
+                <a:latin typeface="Inter"/>
+              </a:rPr>
+              <a:t>Rede de oncologia e tratamentos especializados.</a:t>
+            </a:r>
+          </a:p>
+        </p:txBody>
+      </p:sp>
+      <p:sp>
+        <p:nvSpPr>
+          <p:cNvPr id="18" name="Rectangle 17"/>
           <p:cNvSpPr/>
           <p:nvPr/>
         </p:nvSpPr>
         <p:spPr>
           <a:xfrm>
-            <a:off x="6141567" y="4434840"/>
-            <a:ext cx="2659303" cy="640080"/>
+            <a:off x="5041270" y="3611880"/>
+            <a:ext cx="2109155" cy="1691640"/>
           </a:xfrm>
           <a:prstGeom prst="rect">
             <a:avLst/>
@@ -16903,7 +16397,6 @@
             <a:solidFill>
               <a:srgbClr val="D1D5DB"/>
             </a:solidFill>
-            <a:prstDash val="dash"/>
           </a:ln>
           <a:effectLst/>
         </p:spPr>
@@ -16931,52 +16424,136 @@
       </p:sp>
       <p:sp>
         <p:nvSpPr>
-          <p:cNvPr id="32" name="TextBox 31"/>
-          <p:cNvSpPr txBox="1"/>
-          <p:nvPr/>
-        </p:nvSpPr>
-        <p:spPr>
-          <a:xfrm>
-            <a:off x="6141567" y="4434840"/>
-            <a:ext cx="2659303" cy="640080"/>
-          </a:xfrm>
-          <a:prstGeom prst="rect">
-            <a:avLst/>
-          </a:prstGeom>
-          <a:noFill/>
-          <a:ln>
-            <a:noFill/>
-          </a:ln>
-        </p:spPr>
-        <p:txBody>
-          <a:bodyPr wrap="square" lIns="0" tIns="0" rIns="0" bIns="0" anchor="ctr">
-            <a:spAutoFit/>
-          </a:bodyPr>
-          <a:lstStyle/>
-          <a:p>
-            <a:pPr algn="ctr"/>
-            <a:r>
-              <a:rPr sz="1050" b="0" i="0">
-                <a:solidFill>
-                  <a:srgbClr val="9CA3AF"/>
-                </a:solidFill>
-                <a:latin typeface="Inter"/>
-              </a:rPr>
-              <a:t>[ POC / Conversa comercial ]</a:t>
-            </a:r>
-          </a:p>
-        </p:txBody>
-      </p:sp>
-      <p:sp>
-        <p:nvSpPr>
-          <p:cNvPr id="33" name="Rectangle 32"/>
+          <p:cNvPr id="19" name="TextBox 18"/>
+          <p:cNvSpPr txBox="1"/>
+          <p:nvPr/>
+        </p:nvSpPr>
+        <p:spPr>
+          <a:xfrm>
+            <a:off x="5205862" y="3776472"/>
+            <a:ext cx="1779971" cy="219456"/>
+          </a:xfrm>
+          <a:prstGeom prst="rect">
+            <a:avLst/>
+          </a:prstGeom>
+          <a:noFill/>
+          <a:ln>
+            <a:noFill/>
+          </a:ln>
+        </p:spPr>
+        <p:txBody>
+          <a:bodyPr wrap="square" lIns="0" tIns="0" rIns="0" bIns="0" anchor="t">
+            <a:spAutoFit/>
+          </a:bodyPr>
+          <a:lstStyle/>
+          <a:p>
+            <a:pPr algn="l"/>
+            <a:r>
+              <a:rPr sz="800" b="1" i="0" spc="170">
+                <a:solidFill>
+                  <a:srgbClr val="0071BC"/>
+                </a:solidFill>
+                <a:latin typeface="JetBrains Mono"/>
+              </a:rPr>
+              <a:t>DIAGNÓSTICO</a:t>
+            </a:r>
+          </a:p>
+        </p:txBody>
+      </p:sp>
+      <p:sp>
+        <p:nvSpPr>
+          <p:cNvPr id="20" name="TextBox 19"/>
+          <p:cNvSpPr txBox="1"/>
+          <p:nvPr/>
+        </p:nvSpPr>
+        <p:spPr>
+          <a:xfrm>
+            <a:off x="5205862" y="4050792"/>
+            <a:ext cx="1779971" cy="548640"/>
+          </a:xfrm>
+          <a:prstGeom prst="rect">
+            <a:avLst/>
+          </a:prstGeom>
+          <a:noFill/>
+          <a:ln>
+            <a:noFill/>
+          </a:ln>
+        </p:spPr>
+        <p:txBody>
+          <a:bodyPr wrap="square" lIns="0" tIns="0" rIns="0" bIns="0" anchor="t">
+            <a:spAutoFit/>
+          </a:bodyPr>
+          <a:lstStyle/>
+          <a:p>
+            <a:pPr algn="l">
+              <a:lnSpc>
+                <a:spcPct val="110000"/>
+              </a:lnSpc>
+            </a:pPr>
+            <a:r>
+              <a:rPr sz="1400" b="1" i="0" spc="-50">
+                <a:solidFill>
+                  <a:srgbClr val="1A1F2E"/>
+                </a:solidFill>
+                <a:latin typeface="Inter"/>
+              </a:rPr>
+              <a:t>Evidia</a:t>
+            </a:r>
+          </a:p>
+        </p:txBody>
+      </p:sp>
+      <p:sp>
+        <p:nvSpPr>
+          <p:cNvPr id="21" name="TextBox 20"/>
+          <p:cNvSpPr txBox="1"/>
+          <p:nvPr/>
+        </p:nvSpPr>
+        <p:spPr>
+          <a:xfrm>
+            <a:off x="5205862" y="4645152"/>
+            <a:ext cx="1779971" cy="640080"/>
+          </a:xfrm>
+          <a:prstGeom prst="rect">
+            <a:avLst/>
+          </a:prstGeom>
+          <a:noFill/>
+          <a:ln>
+            <a:noFill/>
+          </a:ln>
+        </p:spPr>
+        <p:txBody>
+          <a:bodyPr wrap="square" lIns="0" tIns="0" rIns="0" bIns="0" anchor="t">
+            <a:spAutoFit/>
+          </a:bodyPr>
+          <a:lstStyle/>
+          <a:p>
+            <a:pPr algn="l">
+              <a:lnSpc>
+                <a:spcPct val="140000"/>
+              </a:lnSpc>
+            </a:pPr>
+            <a:r>
+              <a:rPr sz="900" b="0" i="0">
+                <a:solidFill>
+                  <a:srgbClr val="4B5563"/>
+                </a:solidFill>
+                <a:latin typeface="Inter"/>
+              </a:rPr>
+              <a:t>Medicina diagnóstica, imagem e patologia.</a:t>
+            </a:r>
+          </a:p>
+        </p:txBody>
+      </p:sp>
+      <p:sp>
+        <p:nvSpPr>
+          <p:cNvPr id="22" name="Rectangle 21"/>
           <p:cNvSpPr/>
           <p:nvPr/>
         </p:nvSpPr>
         <p:spPr>
           <a:xfrm>
-            <a:off x="8892311" y="4434840"/>
-            <a:ext cx="2659303" cy="640080"/>
+            <a:off x="7241865" y="3611880"/>
+            <a:ext cx="2109155" cy="1691640"/>
           </a:xfrm>
           <a:prstGeom prst="rect">
             <a:avLst/>
@@ -16988,7 +16565,6 @@
             <a:solidFill>
               <a:srgbClr val="D1D5DB"/>
             </a:solidFill>
-            <a:prstDash val="dash"/>
           </a:ln>
           <a:effectLst/>
         </p:spPr>
@@ -17016,52 +16592,94 @@
       </p:sp>
       <p:sp>
         <p:nvSpPr>
-          <p:cNvPr id="34" name="TextBox 33"/>
-          <p:cNvSpPr txBox="1"/>
-          <p:nvPr/>
-        </p:nvSpPr>
-        <p:spPr>
-          <a:xfrm>
-            <a:off x="8892311" y="4434840"/>
-            <a:ext cx="2659303" cy="640080"/>
-          </a:xfrm>
-          <a:prstGeom prst="rect">
-            <a:avLst/>
-          </a:prstGeom>
-          <a:noFill/>
-          <a:ln>
-            <a:noFill/>
-          </a:ln>
-        </p:spPr>
-        <p:txBody>
-          <a:bodyPr wrap="square" lIns="0" tIns="0" rIns="0" bIns="0" anchor="ctr">
-            <a:spAutoFit/>
-          </a:bodyPr>
-          <a:lstStyle/>
-          <a:p>
-            <a:pPr algn="ctr"/>
-            <a:r>
-              <a:rPr sz="1050" b="0" i="0">
-                <a:solidFill>
-                  <a:srgbClr val="9CA3AF"/>
-                </a:solidFill>
-                <a:latin typeface="Inter"/>
-              </a:rPr>
-              <a:t>[ POC / Conversa comercial ]</a:t>
-            </a:r>
-          </a:p>
-        </p:txBody>
-      </p:sp>
-      <p:sp>
-        <p:nvSpPr>
-          <p:cNvPr id="35" name="TextBox 34"/>
-          <p:cNvSpPr txBox="1"/>
-          <p:nvPr/>
-        </p:nvSpPr>
-        <p:spPr>
-          <a:xfrm>
-            <a:off x="640080" y="5257800"/>
-            <a:ext cx="10911535" cy="274320"/>
+          <p:cNvPr id="23" name="TextBox 22"/>
+          <p:cNvSpPr txBox="1"/>
+          <p:nvPr/>
+        </p:nvSpPr>
+        <p:spPr>
+          <a:xfrm>
+            <a:off x="7406457" y="3776472"/>
+            <a:ext cx="1779971" cy="219456"/>
+          </a:xfrm>
+          <a:prstGeom prst="rect">
+            <a:avLst/>
+          </a:prstGeom>
+          <a:noFill/>
+          <a:ln>
+            <a:noFill/>
+          </a:ln>
+        </p:spPr>
+        <p:txBody>
+          <a:bodyPr wrap="square" lIns="0" tIns="0" rIns="0" bIns="0" anchor="t">
+            <a:spAutoFit/>
+          </a:bodyPr>
+          <a:lstStyle/>
+          <a:p>
+            <a:pPr algn="l"/>
+            <a:r>
+              <a:rPr sz="800" b="1" i="0" spc="170">
+                <a:solidFill>
+                  <a:srgbClr val="0071BC"/>
+                </a:solidFill>
+                <a:latin typeface="JetBrains Mono"/>
+              </a:rPr>
+              <a:t>TELEMEDICINA</a:t>
+            </a:r>
+          </a:p>
+        </p:txBody>
+      </p:sp>
+      <p:sp>
+        <p:nvSpPr>
+          <p:cNvPr id="24" name="TextBox 23"/>
+          <p:cNvSpPr txBox="1"/>
+          <p:nvPr/>
+        </p:nvSpPr>
+        <p:spPr>
+          <a:xfrm>
+            <a:off x="7406457" y="4050792"/>
+            <a:ext cx="1779971" cy="548640"/>
+          </a:xfrm>
+          <a:prstGeom prst="rect">
+            <a:avLst/>
+          </a:prstGeom>
+          <a:noFill/>
+          <a:ln>
+            <a:noFill/>
+          </a:ln>
+        </p:spPr>
+        <p:txBody>
+          <a:bodyPr wrap="square" lIns="0" tIns="0" rIns="0" bIns="0" anchor="t">
+            <a:spAutoFit/>
+          </a:bodyPr>
+          <a:lstStyle/>
+          <a:p>
+            <a:pPr algn="l">
+              <a:lnSpc>
+                <a:spcPct val="110000"/>
+              </a:lnSpc>
+            </a:pPr>
+            <a:r>
+              <a:rPr sz="1400" b="1" i="0" spc="-50">
+                <a:solidFill>
+                  <a:srgbClr val="1A1F2E"/>
+                </a:solidFill>
+                <a:latin typeface="Inter"/>
+              </a:rPr>
+              <a:t>Topmed</a:t>
+            </a:r>
+          </a:p>
+        </p:txBody>
+      </p:sp>
+      <p:sp>
+        <p:nvSpPr>
+          <p:cNvPr id="25" name="TextBox 24"/>
+          <p:cNvSpPr txBox="1"/>
+          <p:nvPr/>
+        </p:nvSpPr>
+        <p:spPr>
+          <a:xfrm>
+            <a:off x="7406457" y="4645152"/>
+            <a:ext cx="1779971" cy="640080"/>
           </a:xfrm>
           <a:prstGeom prst="rect">
             <a:avLst/>
@@ -17083,20 +16701,394 @@
               </a:lnSpc>
             </a:pPr>
             <a:r>
-              <a:rPr sz="850" b="0" i="0">
-                <a:solidFill>
-                  <a:srgbClr val="9CA3AF"/>
-                </a:solidFill>
-                <a:latin typeface="Inter"/>
-              </a:rPr>
-              <a:t>Espaço reservado para inserir logos e nomes após validação interna. Não tratar nenhuma instituição como cliente ativo sem confirmação explícita.</a:t>
-            </a:r>
-          </a:p>
-        </p:txBody>
-      </p:sp>
-      <p:sp>
-        <p:nvSpPr>
-          <p:cNvPr id="36" name="TextBox 35"/>
+              <a:rPr sz="900" b="0" i="0">
+                <a:solidFill>
+                  <a:srgbClr val="4B5563"/>
+                </a:solidFill>
+                <a:latin typeface="Inter"/>
+              </a:rPr>
+              <a:t>Telemedicina e atendimento à distância em escala.</a:t>
+            </a:r>
+          </a:p>
+        </p:txBody>
+      </p:sp>
+      <p:sp>
+        <p:nvSpPr>
+          <p:cNvPr id="26" name="Rectangle 25"/>
+          <p:cNvSpPr/>
+          <p:nvPr/>
+        </p:nvSpPr>
+        <p:spPr>
+          <a:xfrm>
+            <a:off x="9442460" y="3611880"/>
+            <a:ext cx="2109155" cy="1691640"/>
+          </a:xfrm>
+          <a:prstGeom prst="rect">
+            <a:avLst/>
+          </a:prstGeom>
+          <a:solidFill>
+            <a:srgbClr val="FFFFFF"/>
+          </a:solidFill>
+          <a:ln w="6000">
+            <a:solidFill>
+              <a:srgbClr val="D1D5DB"/>
+            </a:solidFill>
+          </a:ln>
+          <a:effectLst/>
+        </p:spPr>
+        <p:style>
+          <a:lnRef idx="1">
+            <a:schemeClr val="accent1"/>
+          </a:lnRef>
+          <a:fillRef idx="3">
+            <a:schemeClr val="accent1"/>
+          </a:fillRef>
+          <a:effectRef idx="2">
+            <a:schemeClr val="accent1"/>
+          </a:effectRef>
+          <a:fontRef idx="minor">
+            <a:schemeClr val="lt1"/>
+          </a:fontRef>
+        </p:style>
+        <p:txBody>
+          <a:bodyPr rtlCol="0" anchor="ctr"/>
+          <a:lstStyle/>
+          <a:p>
+            <a:pPr algn="ctr"/>
+          </a:p>
+        </p:txBody>
+      </p:sp>
+      <p:sp>
+        <p:nvSpPr>
+          <p:cNvPr id="27" name="TextBox 26"/>
+          <p:cNvSpPr txBox="1"/>
+          <p:nvPr/>
+        </p:nvSpPr>
+        <p:spPr>
+          <a:xfrm>
+            <a:off x="9607052" y="3776472"/>
+            <a:ext cx="1779971" cy="219456"/>
+          </a:xfrm>
+          <a:prstGeom prst="rect">
+            <a:avLst/>
+          </a:prstGeom>
+          <a:noFill/>
+          <a:ln>
+            <a:noFill/>
+          </a:ln>
+        </p:spPr>
+        <p:txBody>
+          <a:bodyPr wrap="square" lIns="0" tIns="0" rIns="0" bIns="0" anchor="t">
+            <a:spAutoFit/>
+          </a:bodyPr>
+          <a:lstStyle/>
+          <a:p>
+            <a:pPr algn="l"/>
+            <a:r>
+              <a:rPr sz="800" b="1" i="0" spc="170">
+                <a:solidFill>
+                  <a:srgbClr val="0071BC"/>
+                </a:solidFill>
+                <a:latin typeface="JetBrains Mono"/>
+              </a:rPr>
+              <a:t>OPERADORA VERTICALIZADA</a:t>
+            </a:r>
+          </a:p>
+        </p:txBody>
+      </p:sp>
+      <p:sp>
+        <p:nvSpPr>
+          <p:cNvPr id="28" name="TextBox 27"/>
+          <p:cNvSpPr txBox="1"/>
+          <p:nvPr/>
+        </p:nvSpPr>
+        <p:spPr>
+          <a:xfrm>
+            <a:off x="9607052" y="4050792"/>
+            <a:ext cx="1779971" cy="548640"/>
+          </a:xfrm>
+          <a:prstGeom prst="rect">
+            <a:avLst/>
+          </a:prstGeom>
+          <a:noFill/>
+          <a:ln>
+            <a:noFill/>
+          </a:ln>
+        </p:spPr>
+        <p:txBody>
+          <a:bodyPr wrap="square" lIns="0" tIns="0" rIns="0" bIns="0" anchor="t">
+            <a:spAutoFit/>
+          </a:bodyPr>
+          <a:lstStyle/>
+          <a:p>
+            <a:pPr algn="l">
+              <a:lnSpc>
+                <a:spcPct val="110000"/>
+              </a:lnSpc>
+            </a:pPr>
+            <a:r>
+              <a:rPr sz="1400" b="1" i="0" spc="-50">
+                <a:solidFill>
+                  <a:srgbClr val="1A1F2E"/>
+                </a:solidFill>
+                <a:latin typeface="Inter"/>
+              </a:rPr>
+              <a:t>Leve Saúde</a:t>
+            </a:r>
+          </a:p>
+        </p:txBody>
+      </p:sp>
+      <p:sp>
+        <p:nvSpPr>
+          <p:cNvPr id="29" name="TextBox 28"/>
+          <p:cNvSpPr txBox="1"/>
+          <p:nvPr/>
+        </p:nvSpPr>
+        <p:spPr>
+          <a:xfrm>
+            <a:off x="9607052" y="4645152"/>
+            <a:ext cx="1779971" cy="640080"/>
+          </a:xfrm>
+          <a:prstGeom prst="rect">
+            <a:avLst/>
+          </a:prstGeom>
+          <a:noFill/>
+          <a:ln>
+            <a:noFill/>
+          </a:ln>
+        </p:spPr>
+        <p:txBody>
+          <a:bodyPr wrap="square" lIns="0" tIns="0" rIns="0" bIns="0" anchor="t">
+            <a:spAutoFit/>
+          </a:bodyPr>
+          <a:lstStyle/>
+          <a:p>
+            <a:pPr algn="l">
+              <a:lnSpc>
+                <a:spcPct val="140000"/>
+              </a:lnSpc>
+            </a:pPr>
+            <a:r>
+              <a:rPr sz="900" b="0" i="0">
+                <a:solidFill>
+                  <a:srgbClr val="4B5563"/>
+                </a:solidFill>
+                <a:latin typeface="Inter"/>
+              </a:rPr>
+              <a:t>Operadora verticalizada com modelo próprio de cuidado.</a:t>
+            </a:r>
+          </a:p>
+        </p:txBody>
+      </p:sp>
+      <p:sp>
+        <p:nvSpPr>
+          <p:cNvPr id="30" name="Rectangle 29"/>
+          <p:cNvSpPr/>
+          <p:nvPr/>
+        </p:nvSpPr>
+        <p:spPr>
+          <a:xfrm>
+            <a:off x="640080" y="5440680"/>
+            <a:ext cx="10911535" cy="960120"/>
+          </a:xfrm>
+          <a:prstGeom prst="rect">
+            <a:avLst/>
+          </a:prstGeom>
+          <a:solidFill>
+            <a:srgbClr val="FFFFFF"/>
+          </a:solidFill>
+          <a:ln w="6000">
+            <a:solidFill>
+              <a:srgbClr val="D1D5DB"/>
+            </a:solidFill>
+          </a:ln>
+          <a:effectLst/>
+        </p:spPr>
+        <p:style>
+          <a:lnRef idx="1">
+            <a:schemeClr val="accent1"/>
+          </a:lnRef>
+          <a:fillRef idx="3">
+            <a:schemeClr val="accent1"/>
+          </a:fillRef>
+          <a:effectRef idx="2">
+            <a:schemeClr val="accent1"/>
+          </a:effectRef>
+          <a:fontRef idx="minor">
+            <a:schemeClr val="lt1"/>
+          </a:fontRef>
+        </p:style>
+        <p:txBody>
+          <a:bodyPr rtlCol="0" anchor="ctr"/>
+          <a:lstStyle/>
+          <a:p>
+            <a:pPr algn="ctr"/>
+          </a:p>
+        </p:txBody>
+      </p:sp>
+      <p:sp>
+        <p:nvSpPr>
+          <p:cNvPr id="31" name="TextBox 30"/>
+          <p:cNvSpPr txBox="1"/>
+          <p:nvPr/>
+        </p:nvSpPr>
+        <p:spPr>
+          <a:xfrm>
+            <a:off x="896112" y="5486400"/>
+            <a:ext cx="1463040" cy="960120"/>
+          </a:xfrm>
+          <a:prstGeom prst="rect">
+            <a:avLst/>
+          </a:prstGeom>
+          <a:noFill/>
+          <a:ln>
+            <a:noFill/>
+          </a:ln>
+        </p:spPr>
+        <p:txBody>
+          <a:bodyPr wrap="square" lIns="0" tIns="0" rIns="0" bIns="0" anchor="ctr">
+            <a:spAutoFit/>
+          </a:bodyPr>
+          <a:lstStyle/>
+          <a:p>
+            <a:pPr algn="l">
+              <a:lnSpc>
+                <a:spcPct val="100000"/>
+              </a:lnSpc>
+            </a:pPr>
+            <a:r>
+              <a:rPr sz="3800" b="1" i="0" spc="-200">
+                <a:solidFill>
+                  <a:srgbClr val="1A1F2E"/>
+                </a:solidFill>
+                <a:latin typeface="Inter"/>
+              </a:rPr>
+              <a:t>+25</a:t>
+            </a:r>
+          </a:p>
+        </p:txBody>
+      </p:sp>
+      <p:sp>
+        <p:nvSpPr>
+          <p:cNvPr id="32" name="TextBox 31"/>
+          <p:cNvSpPr txBox="1"/>
+          <p:nvPr/>
+        </p:nvSpPr>
+        <p:spPr>
+          <a:xfrm>
+            <a:off x="2423160" y="5586984"/>
+            <a:ext cx="8899855" cy="274320"/>
+          </a:xfrm>
+          <a:prstGeom prst="rect">
+            <a:avLst/>
+          </a:prstGeom>
+          <a:noFill/>
+          <a:ln>
+            <a:noFill/>
+          </a:ln>
+        </p:spPr>
+        <p:txBody>
+          <a:bodyPr wrap="square" lIns="0" tIns="0" rIns="0" bIns="0" anchor="t">
+            <a:spAutoFit/>
+          </a:bodyPr>
+          <a:lstStyle/>
+          <a:p>
+            <a:pPr algn="l">
+              <a:lnSpc>
+                <a:spcPct val="100000"/>
+              </a:lnSpc>
+            </a:pPr>
+            <a:r>
+              <a:rPr sz="1500" b="1" i="0" spc="-40">
+                <a:solidFill>
+                  <a:srgbClr val="1A1F2E"/>
+                </a:solidFill>
+                <a:latin typeface="Inter"/>
+              </a:rPr>
+              <a:t>unidades / operadoras</a:t>
+            </a:r>
+          </a:p>
+        </p:txBody>
+      </p:sp>
+      <p:sp>
+        <p:nvSpPr>
+          <p:cNvPr id="33" name="TextBox 32"/>
+          <p:cNvSpPr txBox="1"/>
+          <p:nvPr/>
+        </p:nvSpPr>
+        <p:spPr>
+          <a:xfrm>
+            <a:off x="2423160" y="5824728"/>
+            <a:ext cx="8899855" cy="256032"/>
+          </a:xfrm>
+          <a:prstGeom prst="rect">
+            <a:avLst/>
+          </a:prstGeom>
+          <a:noFill/>
+          <a:ln>
+            <a:noFill/>
+          </a:ln>
+        </p:spPr>
+        <p:txBody>
+          <a:bodyPr wrap="square" lIns="0" tIns="0" rIns="0" bIns="0" anchor="t">
+            <a:spAutoFit/>
+          </a:bodyPr>
+          <a:lstStyle/>
+          <a:p>
+            <a:pPr algn="l"/>
+            <a:r>
+              <a:rPr sz="1050" b="0" i="0">
+                <a:solidFill>
+                  <a:srgbClr val="4B5563"/>
+                </a:solidFill>
+                <a:latin typeface="Inter"/>
+              </a:rPr>
+              <a:t>Operadoras verticalizadas e redes regionais</a:t>
+            </a:r>
+          </a:p>
+        </p:txBody>
+      </p:sp>
+      <p:sp>
+        <p:nvSpPr>
+          <p:cNvPr id="34" name="TextBox 33"/>
+          <p:cNvSpPr txBox="1"/>
+          <p:nvPr/>
+        </p:nvSpPr>
+        <p:spPr>
+          <a:xfrm>
+            <a:off x="2423160" y="6062472"/>
+            <a:ext cx="8899855" cy="256032"/>
+          </a:xfrm>
+          <a:prstGeom prst="rect">
+            <a:avLst/>
+          </a:prstGeom>
+          <a:noFill/>
+          <a:ln>
+            <a:noFill/>
+          </a:ln>
+        </p:spPr>
+        <p:txBody>
+          <a:bodyPr wrap="square" lIns="0" tIns="0" rIns="0" bIns="0" anchor="t">
+            <a:spAutoFit/>
+          </a:bodyPr>
+          <a:lstStyle/>
+          <a:p>
+            <a:pPr algn="l"/>
+            <a:r>
+              <a:rPr sz="1100" b="1" i="0" spc="-30">
+                <a:solidFill>
+                  <a:srgbClr val="0071BC"/>
+                </a:solidFill>
+                <a:latin typeface="Inter"/>
+              </a:rPr>
+              <a:t>Replicação do modelo de prontuário-com-IA em rede credenciada</a:t>
+            </a:r>
+          </a:p>
+        </p:txBody>
+      </p:sp>
+      <p:sp>
+        <p:nvSpPr>
+          <p:cNvPr id="35" name="TextBox 34"/>
           <p:cNvSpPr txBox="1"/>
           <p:nvPr/>
         </p:nvSpPr>
@@ -17134,7 +17126,7 @@
       </p:sp>
       <p:sp>
         <p:nvSpPr>
-          <p:cNvPr id="37" name="TextBox 36"/>
+          <p:cNvPr id="36" name="TextBox 35"/>
           <p:cNvSpPr txBox="1"/>
           <p:nvPr/>
         </p:nvSpPr>

</xml_diff>